<commit_message>
feat: add isolated KM A2A delegation bridge
</commit_message>
<xml_diff>
--- a/ANRITSU_AGENT_A2A_IMPLEMENTATION_GUIDE.pptx
+++ b/ANRITSU_AGENT_A2A_IMPLEMENTATION_GUIDE.pptx
@@ -3200,7 +3200,7 @@
                 </a:solidFill>
                 <a:latin typeface="Noto Sans CJK TC"/>
               </a:rPr>
-              <a:t>Anritsu Agent × KB Agent</a:t>
+              <a:t>KM Central Agent × Test Agents</a:t>
             </a:r>
           </a:p>
         </p:txBody>
@@ -3290,7 +3290,7 @@
                 </a:solidFill>
                 <a:latin typeface="Noto Sans CJK TC"/>
               </a:rPr>
-              <a:t>讓 KB Agent 可以安全委派 Anritsu Agent 執行測試，
+              <a:t>讓 KM 中央 Agent 安全委派 Anritsu／Amarisoft Agent 執行測試，
 並沿用既有 Excel 上傳與 Neo4j / Qdrant 攝入流程。</a:t>
             </a:r>
           </a:p>
@@ -3381,7 +3381,7 @@
                 </a:solidFill>
                 <a:latin typeface="Noto Sans CJK TC"/>
               </a:rPr>
-              <a:t>核心原則：A2A 只負責 Agent-to-Agent 委派；儀器控制留在 Anritsu；KB 核心服務不重寫。</a:t>
+              <a:t>核心原則：KM 集中協調；測試 Agent 獨立執行；儀器控制留在測試端；KM 核心服務不重寫。</a:t>
             </a:r>
           </a:p>
         </p:txBody>
@@ -3900,8 +3900,8 @@
                 </a:solidFill>
                 <a:latin typeface="Noto Sans CJK TC"/>
               </a:rPr>
-              <a:t>已接受
-建立 task / run_id</a:t>
+              <a:t>已提交
+KM 可隨時送出 request</a:t>
             </a:r>
           </a:p>
         </p:txBody>
@@ -3991,7 +3991,7 @@
                 </a:solidFill>
                 <a:latin typeface="Noto Sans CJK TC"/>
               </a:rPr>
-              <a:t>working</a:t>
+              <a:t>queued</a:t>
             </a:r>
           </a:p>
         </p:txBody>
@@ -4036,8 +4036,8 @@
                 </a:solidFill>
                 <a:latin typeface="Noto Sans CJK TC"/>
               </a:rPr>
-              <a:t>執行中
-控制儀器 / iperf</a:t>
+              <a:t>已排隊
+尚未取得 instrument lock</a:t>
             </a:r>
           </a:p>
         </p:txBody>
@@ -4127,7 +4127,7 @@
                 </a:solidFill>
                 <a:latin typeface="Noto Sans CJK TC"/>
               </a:rPr>
-              <a:t>input-required</a:t>
+              <a:t>working</a:t>
             </a:r>
           </a:p>
         </p:txBody>
@@ -4172,8 +4172,8 @@
                 </a:solidFill>
                 <a:latin typeface="Noto Sans CJK TC"/>
               </a:rPr>
-              <a:t>需補資料
-缺少參數或人工確認</a:t>
+              <a:t>執行中
+已取得 lock／控制儀器</a:t>
             </a:r>
           </a:p>
         </p:txBody>
@@ -4308,8 +4308,8 @@
                 </a:solidFill>
                 <a:latin typeface="Noto Sans CJK TC"/>
               </a:rPr>
-              <a:t>完成
-Excel 已上傳並攝入</a:t>
+              <a:t>A2A 工作終止
+依 artifact 查看三種狀態</a:t>
             </a:r>
           </a:p>
         </p:txBody>
@@ -4399,7 +4399,7 @@
                 </a:solidFill>
                 <a:latin typeface="Noto Sans CJK TC"/>
               </a:rPr>
-              <a:t>failed</a:t>
+              <a:t>rejected</a:t>
             </a:r>
           </a:p>
         </p:txBody>
@@ -4444,8 +4444,8 @@
                 </a:solidFill>
                 <a:latin typeface="Noto Sans CJK TC"/>
               </a:rPr>
-              <a:t>失敗
-保留錯誤與 log</a:t>
+              <a:t>拒絕
+busy／policy／capacity reason</a:t>
             </a:r>
           </a:p>
         </p:txBody>
@@ -4535,7 +4535,7 @@
                 </a:solidFill>
                 <a:latin typeface="Noto Sans CJK TC"/>
               </a:rPr>
-              <a:t>canceled</a:t>
+              <a:t>failed / canceled</a:t>
             </a:r>
           </a:p>
         </p:txBody>
@@ -4580,8 +4580,8 @@
                 </a:solidFill>
                 <a:latin typeface="Noto Sans CJK TC"/>
               </a:rPr>
-              <a:t>取消
-停止可停止的工作</a:t>
+              <a:t>失敗／取消
+保留 error、cleanup、log</a:t>
             </a:r>
           </a:p>
         </p:txBody>
@@ -4639,8 +4639,8 @@
         </p:nvSpPr>
         <p:spPr>
           <a:xfrm>
-            <a:off x="987552" y="4846320"/>
-            <a:ext cx="10149840" cy="621792"/>
+            <a:off x="987552" y="4782312"/>
+            <a:ext cx="10149840" cy="749808"/>
           </a:xfrm>
           <a:prstGeom prst="rect">
             <a:avLst/>
@@ -4665,14 +4665,14 @@
               </a:spcAft>
             </a:pPr>
             <a:r>
-              <a:rPr sz="1100" b="1">
+              <a:rPr sz="1000" b="1">
                 <a:solidFill>
                   <a:srgbClr val="C87512"/>
                 </a:solidFill>
                 <a:latin typeface="Noto Sans CJK TC"/>
               </a:rPr>
-              <a:t>重點：若 Excel 上傳成功但攝入失敗，Task 必須顯示明確失敗；不能回報整體 completed。
-可重試時沿用相同 run_id / idempotency 規則，避免重複測試或重複寫入。</a:t>
+              <a:t>A2A completed 不等於 KB ingest completed。必須分別回報 test_status、report_status、ingest_status。
+KM 可隨時 submit，但 Agent 必須 queue、取得 lock 後執行，或以穩定 machine-readable reason reject。重試不得重跑實體測試。</a:t>
             </a:r>
           </a:p>
         </p:txBody>
@@ -7982,7 +7982,7 @@
                 </a:solidFill>
                 <a:latin typeface="Noto Sans CJK TC"/>
               </a:rPr>
-              <a:t>分開顯示 test completed 與 ingest failed</a:t>
+              <a:t>分開顯示 test/report/ingest status</a:t>
             </a:r>
           </a:p>
         </p:txBody>
@@ -8201,13 +8201,13 @@
               </a:spcAft>
             </a:pPr>
             <a:r>
-              <a:rPr sz="1100" b="1">
+              <a:rPr sz="1000" b="1">
                 <a:solidFill>
                   <a:srgbClr val="0B1F33"/>
                 </a:solidFill>
                 <a:latin typeface="Noto Sans CJK TC"/>
               </a:rPr>
-              <a:t>A2A taskId、run_id、KB task_id、file_hash 必須一起寫入 audit / local state。</a:t>
+              <a:t>context_id、a2a_task_id、run_id、ingest_task_id、file_hash 必須一起寫入 audit / local state。</a:t>
             </a:r>
           </a:p>
         </p:txBody>
@@ -9849,7 +9849,7 @@
                 </a:solidFill>
                 <a:latin typeface="Noto Sans CJK TC"/>
               </a:rPr>
-              <a:t>雙狀態 + reconciliation</a:t>
+              <a:t>三狀態 + reconciliation</a:t>
             </a:r>
           </a:p>
         </p:txBody>
@@ -12082,11 +12082,11 @@
                 </a:solidFill>
                 <a:latin typeface="Noto Sans CJK TC"/>
               </a:rPr>
-              <a:t>• 人工測試中 A2A 回 busy
+              <a:t>• 人工測試中回 queued 或 rejected
+• rejected 帶穩定 reason code
 • A2A 中人工入口顯示占用
 • 第二個 task 不得控制儀器
 • timeout 後 lock 必須釋放
-• iperf process 無殘留
 • 儀器回到已知 safe state</a:t>
             </a:r>
           </a:p>
@@ -12334,7 +12334,7 @@
                 </a:solidFill>
                 <a:latin typeface="Noto Sans CJK TC"/>
               </a:rPr>
-              <a:t>測試完成不等於攝入完成；兩種狀態必須分開</a:t>
+              <a:t>測試、報告、攝入是三個獨立生命週期</a:t>
             </a:r>
           </a:p>
         </p:txBody>
@@ -12747,7 +12747,7 @@
               <a:t>• 先寫 .tmp，再 atomic rename
 • 每個 run 使用唯一目錄
 • 關閉 workbook 後才計算 hash
-• 分開 test_status / ingest_status
+• test / report / ingest 三狀態分離
 • 沿用 strict headers / KM_Metadata
 • outbox + reconciliation + polling</a:t>
             </a:r>
@@ -12947,8 +12947,8 @@
         </p:nvSpPr>
         <p:spPr>
           <a:xfrm>
-            <a:off x="960120" y="5321808"/>
-            <a:ext cx="10241280" cy="329184"/>
+            <a:off x="960120" y="5285232"/>
+            <a:ext cx="10241280" cy="402336"/>
           </a:xfrm>
           <a:prstGeom prst="rect">
             <a:avLst/>
@@ -12973,13 +12973,13 @@
               </a:spcAft>
             </a:pPr>
             <a:r>
-              <a:rPr sz="1100" b="1">
+              <a:rPr sz="1000" b="1">
                 <a:solidFill>
                   <a:srgbClr val="C87512"/>
                 </a:solidFill>
                 <a:latin typeface="Noto Sans CJK TC"/>
               </a:rPr>
-              <a:t>A2A completion artifact 應回傳 run_id、report_name、file_hash、KB task_id、test_status、ingest_status。</a:t>
+              <a:t>A2A artifact：context_id、a2a_task_id、run_id、ingest_task_id、report_name、file_hash、test_status、report_status、ingest_status。</a:t>
             </a:r>
           </a:p>
         </p:txBody>
@@ -14555,8 +14555,8 @@
         </p:nvSpPr>
         <p:spPr>
           <a:xfrm>
-            <a:off x="960120" y="5321808"/>
-            <a:ext cx="10241280" cy="329184"/>
+            <a:off x="960120" y="5285232"/>
+            <a:ext cx="10241280" cy="402336"/>
           </a:xfrm>
           <a:prstGeom prst="rect">
             <a:avLst/>
@@ -14581,13 +14581,13 @@
               </a:spcAft>
             </a:pPr>
             <a:r>
-              <a:rPr sz="1000" b="1">
+              <a:rPr sz="900" b="1">
                 <a:solidFill>
                   <a:srgbClr val="0B1F33"/>
                 </a:solidFill>
                 <a:latin typeface="Noto Sans CJK TC"/>
               </a:rPr>
-              <a:t>最低 audit 欄位：timestamp、caller、profile_id、run_id、A2A taskId、KB task_id、state、error_code、file_hash。</a:t>
+              <a:t>最低 audit：timestamp、caller、profile_id、context_id、a2a_task_id、run_id、ingest_task_id、三種 status、error_code、file_hash。</a:t>
             </a:r>
           </a:p>
         </p:txBody>
@@ -15010,15 +15010,15 @@
               </a:spcAft>
             </a:pPr>
             <a:r>
-              <a:rPr sz="1200" b="0">
+              <a:rPr sz="1100" b="0">
                 <a:solidFill>
                   <a:srgbClr val="193247"/>
                 </a:solidFill>
                 <a:latin typeface="Noto Sans CJK TC"/>
               </a:rPr>
-              <a:t>KB Agent = A2A Client
-Anritsu Agent = A2A Server
-Anritsu 端保留儀器控制權</a:t>
+              <a:t>KM = Central Orchestrator / Control Plane
+Bridge = outbound A2A Client
+測試端 = 獨立 A2A Server / Execution Plane</a:t>
             </a:r>
           </a:p>
         </p:txBody>
@@ -15470,7 +15470,7 @@
                 </a:solidFill>
                 <a:latin typeface="Noto Sans CJK TC"/>
               </a:rPr>
-              <a:t>A2A Server、Agent Card、Task executor、權限與狀態管理</a:t>
+              <a:t>獨立 A2A Server、Agent Card、Task executor、queue / reject、權限與狀態管理</a:t>
             </a:r>
           </a:p>
         </p:txBody>
@@ -16208,7 +16208,7 @@
                 </a:solidFill>
                 <a:latin typeface="Noto Sans CJK TC"/>
               </a:rPr>
-              <a:t>契約與 dry-run</a:t>
+              <a:t>Mock</a:t>
             </a:r>
           </a:p>
         </p:txBody>
@@ -16221,8 +16221,8 @@
         </p:nvSpPr>
         <p:spPr>
           <a:xfrm>
-            <a:off x="667512" y="2679192"/>
-            <a:ext cx="1664208" cy="960120"/>
+            <a:off x="667512" y="2587752"/>
+            <a:ext cx="1664208" cy="1325880"/>
           </a:xfrm>
           <a:prstGeom prst="rect">
             <a:avLst/>
@@ -16247,15 +16247,15 @@
               </a:spcAft>
             </a:pPr>
             <a:r>
-              <a:rPr sz="1100" b="0">
+              <a:rPr sz="900" b="0">
                 <a:solidFill>
                   <a:srgbClr val="193247"/>
                 </a:solidFill>
                 <a:latin typeface="Noto Sans CJK TC"/>
               </a:rPr>
-              <a:t>Agent Card
-job schema
-不控制儀器</a:t>
+              <a:t>Mock A2A server
+完整 task lifecycle
+不碰真實儀器</a:t>
             </a:r>
           </a:p>
         </p:txBody>
@@ -16305,6 +16305,267 @@
         <p:spPr>
           <a:xfrm>
             <a:off x="2862072" y="1600200"/>
+            <a:ext cx="1938528" cy="2926080"/>
+          </a:xfrm>
+          <a:prstGeom prst="roundRect">
+            <a:avLst/>
+          </a:prstGeom>
+          <a:solidFill>
+            <a:srgbClr val="F1ECFA"/>
+          </a:solidFill>
+          <a:ln w="17780">
+            <a:solidFill>
+              <a:srgbClr val="7653A6"/>
+            </a:solidFill>
+          </a:ln>
+        </p:spPr>
+        <p:style>
+          <a:lnRef idx="1">
+            <a:schemeClr val="accent1"/>
+          </a:lnRef>
+          <a:fillRef idx="3">
+            <a:schemeClr val="accent1"/>
+          </a:fillRef>
+          <a:effectRef idx="2">
+            <a:schemeClr val="accent1"/>
+          </a:effectRef>
+          <a:fontRef idx="minor">
+            <a:schemeClr val="lt1"/>
+          </a:fontRef>
+        </p:style>
+        <p:txBody>
+          <a:bodyPr rtlCol="0" anchor="ctr"/>
+          <a:lstStyle/>
+          <a:p>
+            <a:pPr algn="ctr"/>
+          </a:p>
+        </p:txBody>
+      </p:sp>
+      <p:sp>
+        <p:nvSpPr>
+          <p:cNvPr id="15" name="Rounded Rectangle 14"/>
+          <p:cNvSpPr/>
+          <p:nvPr/>
+        </p:nvSpPr>
+        <p:spPr>
+          <a:xfrm>
+            <a:off x="3346704" y="1371600"/>
+            <a:ext cx="960120" cy="292608"/>
+          </a:xfrm>
+          <a:prstGeom prst="roundRect">
+            <a:avLst/>
+          </a:prstGeom>
+          <a:solidFill>
+            <a:srgbClr val="7653A6"/>
+          </a:solidFill>
+          <a:ln>
+            <a:noFill/>
+          </a:ln>
+        </p:spPr>
+        <p:style>
+          <a:lnRef idx="1">
+            <a:schemeClr val="accent1"/>
+          </a:lnRef>
+          <a:fillRef idx="3">
+            <a:schemeClr val="accent1"/>
+          </a:fillRef>
+          <a:effectRef idx="2">
+            <a:schemeClr val="accent1"/>
+          </a:effectRef>
+          <a:fontRef idx="minor">
+            <a:schemeClr val="lt1"/>
+          </a:fontRef>
+        </p:style>
+        <p:txBody>
+          <a:bodyPr rtlCol="0" anchor="ctr"/>
+          <a:lstStyle/>
+          <a:p>
+            <a:pPr algn="ctr"/>
+          </a:p>
+        </p:txBody>
+      </p:sp>
+      <p:sp>
+        <p:nvSpPr>
+          <p:cNvPr id="16" name="TextBox 15"/>
+          <p:cNvSpPr txBox="1"/>
+          <p:nvPr/>
+        </p:nvSpPr>
+        <p:spPr>
+          <a:xfrm>
+            <a:off x="3346704" y="1380744"/>
+            <a:ext cx="960120" cy="228600"/>
+          </a:xfrm>
+          <a:prstGeom prst="rect">
+            <a:avLst/>
+          </a:prstGeom>
+          <a:noFill/>
+        </p:spPr>
+        <p:txBody>
+          <a:bodyPr wrap="square" anchor="ctr" lIns="88900" rIns="88900" tIns="38100" bIns="38100">
+            <a:normAutofit/>
+          </a:bodyPr>
+          <a:lstStyle/>
+          <a:p>
+            <a:pPr algn="ctr">
+              <a:lnSpc>
+                <a:spcPct val="100000"/>
+              </a:lnSpc>
+              <a:spcBef>
+                <a:spcPts val="0"/>
+              </a:spcBef>
+              <a:spcAft>
+                <a:spcPts val="0"/>
+              </a:spcAft>
+            </a:pPr>
+            <a:r>
+              <a:rPr sz="900" b="1">
+                <a:solidFill>
+                  <a:srgbClr val="FFFFFF"/>
+                </a:solidFill>
+                <a:latin typeface="Noto Sans CJK TC"/>
+              </a:rPr>
+              <a:t>Phase 1</a:t>
+            </a:r>
+          </a:p>
+        </p:txBody>
+      </p:sp>
+      <p:sp>
+        <p:nvSpPr>
+          <p:cNvPr id="17" name="TextBox 16"/>
+          <p:cNvSpPr txBox="1"/>
+          <p:nvPr/>
+        </p:nvSpPr>
+        <p:spPr>
+          <a:xfrm>
+            <a:off x="2971800" y="1920240"/>
+            <a:ext cx="1719072" cy="530352"/>
+          </a:xfrm>
+          <a:prstGeom prst="rect">
+            <a:avLst/>
+          </a:prstGeom>
+          <a:noFill/>
+        </p:spPr>
+        <p:txBody>
+          <a:bodyPr wrap="square" anchor="ctr" lIns="88900" rIns="88900" tIns="38100" bIns="38100">
+            <a:normAutofit/>
+          </a:bodyPr>
+          <a:lstStyle/>
+          <a:p>
+            <a:pPr algn="ctr">
+              <a:lnSpc>
+                <a:spcPct val="100000"/>
+              </a:lnSpc>
+              <a:spcBef>
+                <a:spcPts val="0"/>
+              </a:spcBef>
+              <a:spcAft>
+                <a:spcPts val="0"/>
+              </a:spcAft>
+            </a:pPr>
+            <a:r>
+              <a:rPr sz="1300" b="1">
+                <a:solidFill>
+                  <a:srgbClr val="7653A6"/>
+                </a:solidFill>
+                <a:latin typeface="Noto Sans CJK TC"/>
+              </a:rPr>
+              <a:t>Dry-run</a:t>
+            </a:r>
+          </a:p>
+        </p:txBody>
+      </p:sp>
+      <p:sp>
+        <p:nvSpPr>
+          <p:cNvPr id="18" name="TextBox 17"/>
+          <p:cNvSpPr txBox="1"/>
+          <p:nvPr/>
+        </p:nvSpPr>
+        <p:spPr>
+          <a:xfrm>
+            <a:off x="2999232" y="2587752"/>
+            <a:ext cx="1664208" cy="1325880"/>
+          </a:xfrm>
+          <a:prstGeom prst="rect">
+            <a:avLst/>
+          </a:prstGeom>
+          <a:noFill/>
+        </p:spPr>
+        <p:txBody>
+          <a:bodyPr wrap="square" anchor="ctr" lIns="88900" rIns="88900" tIns="38100" bIns="38100">
+            <a:normAutofit/>
+          </a:bodyPr>
+          <a:lstStyle/>
+          <a:p>
+            <a:pPr algn="ctr">
+              <a:lnSpc>
+                <a:spcPct val="100000"/>
+              </a:lnSpc>
+              <a:spcBef>
+                <a:spcPts val="0"/>
+              </a:spcBef>
+              <a:spcAft>
+                <a:spcPts val="0"/>
+              </a:spcAft>
+            </a:pPr>
+            <a:r>
+              <a:rPr sz="900" b="0">
+                <a:solidFill>
+                  <a:srgbClr val="193247"/>
+                </a:solidFill>
+                <a:latin typeface="Noto Sans CJK TC"/>
+              </a:rPr>
+              <a:t>Agent Card / schema
+policy / correlation
+不控制儀器</a:t>
+            </a:r>
+          </a:p>
+        </p:txBody>
+      </p:sp>
+      <p:cxnSp>
+        <p:nvCxnSpPr>
+          <p:cNvPr id="19" name="Connector 18"/>
+          <p:cNvCxnSpPr/>
+          <p:nvPr/>
+        </p:nvCxnSpPr>
+        <p:spPr>
+          <a:xfrm>
+            <a:off x="4800600" y="3044952"/>
+            <a:ext cx="393192" cy="0"/>
+          </a:xfrm>
+          <a:prstGeom prst="line">
+            <a:avLst/>
+          </a:prstGeom>
+          <a:ln w="22860">
+            <a:solidFill>
+              <a:srgbClr val="C8D5DF"/>
+            </a:solidFill>
+            <a:tailEnd type="triangle" w="sm" len="sm"/>
+          </a:ln>
+        </p:spPr>
+        <p:style>
+          <a:lnRef idx="2">
+            <a:schemeClr val="accent1"/>
+          </a:lnRef>
+          <a:fillRef idx="0">
+            <a:schemeClr val="accent1"/>
+          </a:fillRef>
+          <a:effectRef idx="1">
+            <a:schemeClr val="accent1"/>
+          </a:effectRef>
+          <a:fontRef idx="minor">
+            <a:schemeClr val="tx1"/>
+          </a:fontRef>
+        </p:style>
+      </p:cxnSp>
+      <p:sp>
+        <p:nvSpPr>
+          <p:cNvPr id="20" name="Rounded Rectangle 19"/>
+          <p:cNvSpPr/>
+          <p:nvPr/>
+        </p:nvSpPr>
+        <p:spPr>
+          <a:xfrm>
+            <a:off x="5193792" y="1600200"/>
             <a:ext cx="1938528" cy="2926080"/>
           </a:xfrm>
           <a:prstGeom prst="roundRect">
@@ -16343,13 +16604,13 @@
       </p:sp>
       <p:sp>
         <p:nvSpPr>
-          <p:cNvPr id="15" name="Rounded Rectangle 14"/>
+          <p:cNvPr id="21" name="Rounded Rectangle 20"/>
           <p:cNvSpPr/>
           <p:nvPr/>
         </p:nvSpPr>
         <p:spPr>
           <a:xfrm>
-            <a:off x="3346704" y="1371600"/>
+            <a:off x="5678424" y="1371600"/>
             <a:ext cx="960120" cy="292608"/>
           </a:xfrm>
           <a:prstGeom prst="roundRect">
@@ -16386,13 +16647,13 @@
       </p:sp>
       <p:sp>
         <p:nvSpPr>
-          <p:cNvPr id="16" name="TextBox 15"/>
-          <p:cNvSpPr txBox="1"/>
-          <p:nvPr/>
-        </p:nvSpPr>
-        <p:spPr>
-          <a:xfrm>
-            <a:off x="3346704" y="1380744"/>
+          <p:cNvPr id="22" name="TextBox 21"/>
+          <p:cNvSpPr txBox="1"/>
+          <p:nvPr/>
+        </p:nvSpPr>
+        <p:spPr>
+          <a:xfrm>
+            <a:off x="5678424" y="1380744"/>
             <a:ext cx="960120" cy="228600"/>
           </a:xfrm>
           <a:prstGeom prst="rect">
@@ -16424,20 +16685,20 @@
                 </a:solidFill>
                 <a:latin typeface="Noto Sans CJK TC"/>
               </a:rPr>
-              <a:t>Phase 1</a:t>
-            </a:r>
-          </a:p>
-        </p:txBody>
-      </p:sp>
-      <p:sp>
-        <p:nvSpPr>
-          <p:cNvPr id="17" name="TextBox 16"/>
-          <p:cNvSpPr txBox="1"/>
-          <p:nvPr/>
-        </p:nvSpPr>
-        <p:spPr>
-          <a:xfrm>
-            <a:off x="2971800" y="1920240"/>
+              <a:t>Phase 2</a:t>
+            </a:r>
+          </a:p>
+        </p:txBody>
+      </p:sp>
+      <p:sp>
+        <p:nvSpPr>
+          <p:cNvPr id="23" name="TextBox 22"/>
+          <p:cNvSpPr txBox="1"/>
+          <p:nvPr/>
+        </p:nvSpPr>
+        <p:spPr>
+          <a:xfrm>
+            <a:off x="5303520" y="1920240"/>
             <a:ext cx="1719072" cy="530352"/>
           </a:xfrm>
           <a:prstGeom prst="rect">
@@ -16469,21 +16730,21 @@
                 </a:solidFill>
                 <a:latin typeface="Noto Sans CJK TC"/>
               </a:rPr>
-              <a:t>單一 profile</a:t>
-            </a:r>
-          </a:p>
-        </p:txBody>
-      </p:sp>
-      <p:sp>
-        <p:nvSpPr>
-          <p:cNvPr id="18" name="TextBox 17"/>
-          <p:cNvSpPr txBox="1"/>
-          <p:nvPr/>
-        </p:nvSpPr>
-        <p:spPr>
-          <a:xfrm>
-            <a:off x="2999232" y="2679192"/>
-            <a:ext cx="1664208" cy="960120"/>
+              <a:t>Anritsu pilot</a:t>
+            </a:r>
+          </a:p>
+        </p:txBody>
+      </p:sp>
+      <p:sp>
+        <p:nvSpPr>
+          <p:cNvPr id="24" name="TextBox 23"/>
+          <p:cNvSpPr txBox="1"/>
+          <p:nvPr/>
+        </p:nvSpPr>
+        <p:spPr>
+          <a:xfrm>
+            <a:off x="5330952" y="2587752"/>
+            <a:ext cx="1664208" cy="1325880"/>
           </a:xfrm>
           <a:prstGeom prst="rect">
             <a:avLst/>
@@ -16508,27 +16769,28 @@
               </a:spcAft>
             </a:pPr>
             <a:r>
-              <a:rPr sz="1100" b="0">
+              <a:rPr sz="900" b="0">
                 <a:solidFill>
                   <a:srgbClr val="193247"/>
                 </a:solidFill>
                 <a:latin typeface="Noto Sans CJK TC"/>
               </a:rPr>
-              <a:t>固定 NCQ profile
-實際執行 iperf</a:t>
+              <a:t>單一 allowlisted profile
+真實 iperf + Excel
+既有 ingest</a:t>
             </a:r>
           </a:p>
         </p:txBody>
       </p:sp>
       <p:cxnSp>
         <p:nvCxnSpPr>
-          <p:cNvPr id="19" name="Connector 18"/>
+          <p:cNvPr id="25" name="Connector 24"/>
           <p:cNvCxnSpPr/>
           <p:nvPr/>
         </p:nvCxnSpPr>
         <p:spPr>
           <a:xfrm>
-            <a:off x="4800600" y="3044952"/>
+            <a:off x="7132320" y="3044952"/>
             <a:ext cx="393192" cy="0"/>
           </a:xfrm>
           <a:prstGeom prst="line">
@@ -16558,13 +16820,13 @@
       </p:cxnSp>
       <p:sp>
         <p:nvSpPr>
-          <p:cNvPr id="20" name="Rounded Rectangle 19"/>
+          <p:cNvPr id="26" name="Rounded Rectangle 25"/>
           <p:cNvSpPr/>
           <p:nvPr/>
         </p:nvSpPr>
         <p:spPr>
           <a:xfrm>
-            <a:off x="5193792" y="1600200"/>
+            <a:off x="7525511" y="1600200"/>
             <a:ext cx="1938528" cy="2926080"/>
           </a:xfrm>
           <a:prstGeom prst="roundRect">
@@ -16603,13 +16865,13 @@
       </p:sp>
       <p:sp>
         <p:nvSpPr>
-          <p:cNvPr id="21" name="Rounded Rectangle 20"/>
+          <p:cNvPr id="27" name="Rounded Rectangle 26"/>
           <p:cNvSpPr/>
           <p:nvPr/>
         </p:nvSpPr>
         <p:spPr>
           <a:xfrm>
-            <a:off x="5678424" y="1371600"/>
+            <a:off x="8010143" y="1371600"/>
             <a:ext cx="960120" cy="292608"/>
           </a:xfrm>
           <a:prstGeom prst="roundRect">
@@ -16646,266 +16908,6 @@
       </p:sp>
       <p:sp>
         <p:nvSpPr>
-          <p:cNvPr id="22" name="TextBox 21"/>
-          <p:cNvSpPr txBox="1"/>
-          <p:nvPr/>
-        </p:nvSpPr>
-        <p:spPr>
-          <a:xfrm>
-            <a:off x="5678424" y="1380744"/>
-            <a:ext cx="960120" cy="228600"/>
-          </a:xfrm>
-          <a:prstGeom prst="rect">
-            <a:avLst/>
-          </a:prstGeom>
-          <a:noFill/>
-        </p:spPr>
-        <p:txBody>
-          <a:bodyPr wrap="square" anchor="ctr" lIns="88900" rIns="88900" tIns="38100" bIns="38100">
-            <a:normAutofit/>
-          </a:bodyPr>
-          <a:lstStyle/>
-          <a:p>
-            <a:pPr algn="ctr">
-              <a:lnSpc>
-                <a:spcPct val="100000"/>
-              </a:lnSpc>
-              <a:spcBef>
-                <a:spcPts val="0"/>
-              </a:spcBef>
-              <a:spcAft>
-                <a:spcPts val="0"/>
-              </a:spcAft>
-            </a:pPr>
-            <a:r>
-              <a:rPr sz="900" b="1">
-                <a:solidFill>
-                  <a:srgbClr val="FFFFFF"/>
-                </a:solidFill>
-                <a:latin typeface="Noto Sans CJK TC"/>
-              </a:rPr>
-              <a:t>Phase 2</a:t>
-            </a:r>
-          </a:p>
-        </p:txBody>
-      </p:sp>
-      <p:sp>
-        <p:nvSpPr>
-          <p:cNvPr id="23" name="TextBox 22"/>
-          <p:cNvSpPr txBox="1"/>
-          <p:nvPr/>
-        </p:nvSpPr>
-        <p:spPr>
-          <a:xfrm>
-            <a:off x="5303520" y="1920240"/>
-            <a:ext cx="1719072" cy="530352"/>
-          </a:xfrm>
-          <a:prstGeom prst="rect">
-            <a:avLst/>
-          </a:prstGeom>
-          <a:noFill/>
-        </p:spPr>
-        <p:txBody>
-          <a:bodyPr wrap="square" anchor="ctr" lIns="88900" rIns="88900" tIns="38100" bIns="38100">
-            <a:normAutofit/>
-          </a:bodyPr>
-          <a:lstStyle/>
-          <a:p>
-            <a:pPr algn="ctr">
-              <a:lnSpc>
-                <a:spcPct val="100000"/>
-              </a:lnSpc>
-              <a:spcBef>
-                <a:spcPts val="0"/>
-              </a:spcBef>
-              <a:spcAft>
-                <a:spcPts val="0"/>
-              </a:spcAft>
-            </a:pPr>
-            <a:r>
-              <a:rPr sz="1300" b="1">
-                <a:solidFill>
-                  <a:srgbClr val="008F89"/>
-                </a:solidFill>
-                <a:latin typeface="Noto Sans CJK TC"/>
-              </a:rPr>
-              <a:t>結果攝入</a:t>
-            </a:r>
-          </a:p>
-        </p:txBody>
-      </p:sp>
-      <p:sp>
-        <p:nvSpPr>
-          <p:cNvPr id="24" name="TextBox 23"/>
-          <p:cNvSpPr txBox="1"/>
-          <p:nvPr/>
-        </p:nvSpPr>
-        <p:spPr>
-          <a:xfrm>
-            <a:off x="5330952" y="2679192"/>
-            <a:ext cx="1664208" cy="960120"/>
-          </a:xfrm>
-          <a:prstGeom prst="rect">
-            <a:avLst/>
-          </a:prstGeom>
-          <a:noFill/>
-        </p:spPr>
-        <p:txBody>
-          <a:bodyPr wrap="square" anchor="ctr" lIns="88900" rIns="88900" tIns="38100" bIns="38100">
-            <a:normAutofit/>
-          </a:bodyPr>
-          <a:lstStyle/>
-          <a:p>
-            <a:pPr algn="ctr">
-              <a:lnSpc>
-                <a:spcPct val="100000"/>
-              </a:lnSpc>
-              <a:spcBef>
-                <a:spcPts val="0"/>
-              </a:spcBef>
-              <a:spcAft>
-                <a:spcPts val="0"/>
-              </a:spcAft>
-            </a:pPr>
-            <a:r>
-              <a:rPr sz="1100" b="0">
-                <a:solidFill>
-                  <a:srgbClr val="193247"/>
-                </a:solidFill>
-                <a:latin typeface="Noto Sans CJK TC"/>
-              </a:rPr>
-              <a:t>沿用 Excel upload
-驗證 Neo4j/Qdrant</a:t>
-            </a:r>
-          </a:p>
-        </p:txBody>
-      </p:sp>
-      <p:cxnSp>
-        <p:nvCxnSpPr>
-          <p:cNvPr id="25" name="Connector 24"/>
-          <p:cNvCxnSpPr/>
-          <p:nvPr/>
-        </p:nvCxnSpPr>
-        <p:spPr>
-          <a:xfrm>
-            <a:off x="7132320" y="3044952"/>
-            <a:ext cx="393192" cy="0"/>
-          </a:xfrm>
-          <a:prstGeom prst="line">
-            <a:avLst/>
-          </a:prstGeom>
-          <a:ln w="22860">
-            <a:solidFill>
-              <a:srgbClr val="C8D5DF"/>
-            </a:solidFill>
-            <a:tailEnd type="triangle" w="sm" len="sm"/>
-          </a:ln>
-        </p:spPr>
-        <p:style>
-          <a:lnRef idx="2">
-            <a:schemeClr val="accent1"/>
-          </a:lnRef>
-          <a:fillRef idx="0">
-            <a:schemeClr val="accent1"/>
-          </a:fillRef>
-          <a:effectRef idx="1">
-            <a:schemeClr val="accent1"/>
-          </a:effectRef>
-          <a:fontRef idx="minor">
-            <a:schemeClr val="tx1"/>
-          </a:fontRef>
-        </p:style>
-      </p:cxnSp>
-      <p:sp>
-        <p:nvSpPr>
-          <p:cNvPr id="26" name="Rounded Rectangle 25"/>
-          <p:cNvSpPr/>
-          <p:nvPr/>
-        </p:nvSpPr>
-        <p:spPr>
-          <a:xfrm>
-            <a:off x="7525511" y="1600200"/>
-            <a:ext cx="1938528" cy="2926080"/>
-          </a:xfrm>
-          <a:prstGeom prst="roundRect">
-            <a:avLst/>
-          </a:prstGeom>
-          <a:solidFill>
-            <a:srgbClr val="F1ECFA"/>
-          </a:solidFill>
-          <a:ln w="17780">
-            <a:solidFill>
-              <a:srgbClr val="7653A6"/>
-            </a:solidFill>
-          </a:ln>
-        </p:spPr>
-        <p:style>
-          <a:lnRef idx="1">
-            <a:schemeClr val="accent1"/>
-          </a:lnRef>
-          <a:fillRef idx="3">
-            <a:schemeClr val="accent1"/>
-          </a:fillRef>
-          <a:effectRef idx="2">
-            <a:schemeClr val="accent1"/>
-          </a:effectRef>
-          <a:fontRef idx="minor">
-            <a:schemeClr val="lt1"/>
-          </a:fontRef>
-        </p:style>
-        <p:txBody>
-          <a:bodyPr rtlCol="0" anchor="ctr"/>
-          <a:lstStyle/>
-          <a:p>
-            <a:pPr algn="ctr"/>
-          </a:p>
-        </p:txBody>
-      </p:sp>
-      <p:sp>
-        <p:nvSpPr>
-          <p:cNvPr id="27" name="Rounded Rectangle 26"/>
-          <p:cNvSpPr/>
-          <p:nvPr/>
-        </p:nvSpPr>
-        <p:spPr>
-          <a:xfrm>
-            <a:off x="8010143" y="1371600"/>
-            <a:ext cx="960120" cy="292608"/>
-          </a:xfrm>
-          <a:prstGeom prst="roundRect">
-            <a:avLst/>
-          </a:prstGeom>
-          <a:solidFill>
-            <a:srgbClr val="7653A6"/>
-          </a:solidFill>
-          <a:ln>
-            <a:noFill/>
-          </a:ln>
-        </p:spPr>
-        <p:style>
-          <a:lnRef idx="1">
-            <a:schemeClr val="accent1"/>
-          </a:lnRef>
-          <a:fillRef idx="3">
-            <a:schemeClr val="accent1"/>
-          </a:fillRef>
-          <a:effectRef idx="2">
-            <a:schemeClr val="accent1"/>
-          </a:effectRef>
-          <a:fontRef idx="minor">
-            <a:schemeClr val="lt1"/>
-          </a:fontRef>
-        </p:style>
-        <p:txBody>
-          <a:bodyPr rtlCol="0" anchor="ctr"/>
-          <a:lstStyle/>
-          <a:p>
-            <a:pPr algn="ctr"/>
-          </a:p>
-        </p:txBody>
-      </p:sp>
-      <p:sp>
-        <p:nvSpPr>
           <p:cNvPr id="28" name="TextBox 27"/>
           <p:cNvSpPr txBox="1"/>
           <p:nvPr/>
@@ -16985,11 +16987,11 @@
             <a:r>
               <a:rPr sz="1300" b="1">
                 <a:solidFill>
-                  <a:srgbClr val="7653A6"/>
-                </a:solidFill>
-                <a:latin typeface="Noto Sans CJK TC"/>
-              </a:rPr>
-              <a:t>可靠性</a:t>
+                  <a:srgbClr val="008F89"/>
+                </a:solidFill>
+                <a:latin typeface="Noto Sans CJK TC"/>
+              </a:rPr>
+              <a:t>Amarisoft</a:t>
             </a:r>
           </a:p>
         </p:txBody>
@@ -17002,8 +17004,8 @@
         </p:nvSpPr>
         <p:spPr>
           <a:xfrm>
-            <a:off x="7662671" y="2679192"/>
-            <a:ext cx="1664208" cy="960120"/>
+            <a:off x="7662671" y="2587752"/>
+            <a:ext cx="1664208" cy="1325880"/>
           </a:xfrm>
           <a:prstGeom prst="rect">
             <a:avLst/>
@@ -17028,14 +17030,15 @@
               </a:spcAft>
             </a:pPr>
             <a:r>
-              <a:rPr sz="1100" b="0">
+              <a:rPr sz="900" b="0">
                 <a:solidFill>
                   <a:srgbClr val="193247"/>
                 </a:solidFill>
                 <a:latin typeface="Noto Sans CJK TC"/>
               </a:rPr>
-              <a:t>取消、timeout
-retry、audit</a:t>
+              <a:t>獨立 A2A Server
+獨立 credential / queue
+相同契約</a:t>
             </a:r>
           </a:p>
         </p:txBody>
@@ -17249,7 +17252,7 @@
                 </a:solidFill>
                 <a:latin typeface="Noto Sans CJK TC"/>
               </a:rPr>
-              <a:t>擴充</a:t>
+              <a:t>Concurrency</a:t>
             </a:r>
           </a:p>
         </p:txBody>
@@ -17262,8 +17265,8 @@
         </p:nvSpPr>
         <p:spPr>
           <a:xfrm>
-            <a:off x="9994392" y="2679192"/>
-            <a:ext cx="1664208" cy="960120"/>
+            <a:off x="9994392" y="2587752"/>
+            <a:ext cx="1664208" cy="1325880"/>
           </a:xfrm>
           <a:prstGeom prst="rect">
             <a:avLst/>
@@ -17288,14 +17291,15 @@
               </a:spcAft>
             </a:pPr>
             <a:r>
-              <a:rPr sz="1100" b="0">
+              <a:rPr sz="900" b="0">
                 <a:solidFill>
                   <a:srgbClr val="193247"/>
                 </a:solidFill>
                 <a:latin typeface="Noto Sans CJK TC"/>
               </a:rPr>
-              <a:t>多 profile
-Amarisoft 共用契約</a:t>
+              <a:t>queue / reject / lock
+重啟與網路中斷
+雙環境並行</a:t>
             </a:r>
           </a:p>
         </p:txBody>
@@ -17353,8 +17357,8 @@
         </p:nvSpPr>
         <p:spPr>
           <a:xfrm>
-            <a:off x="987552" y="5175504"/>
-            <a:ext cx="10149840" cy="420624"/>
+            <a:off x="987552" y="5102352"/>
+            <a:ext cx="10149840" cy="566928"/>
           </a:xfrm>
           <a:prstGeom prst="rect">
             <a:avLst/>
@@ -17379,13 +17383,14 @@
               </a:spcAft>
             </a:pPr>
             <a:r>
-              <a:rPr sz="1200" b="1">
+              <a:rPr sz="1000" b="1">
                 <a:solidFill>
                   <a:srgbClr val="0B1F33"/>
                 </a:solidFill>
                 <a:latin typeface="Noto Sans CJK TC"/>
               </a:rPr>
-              <a:t>每一階段都必須能獨立 rollback；任何階段失敗不得影響既有 KB chat、search、ingest 與資料庫。</a:t>
+              <a:t>每階段 gate：timeout / cancel / retry / idempotency、三狀態、audit 與 rollback 都要通過。
+任何失敗不得影響既有手動測試，以及 KM chat、search、ingest、Neo4j / Qdrant。</a:t>
             </a:r>
           </a:p>
         </p:txBody>
@@ -17692,8 +17697,8 @@
         </p:nvSpPr>
         <p:spPr>
           <a:xfrm>
-            <a:off x="749808" y="1307592"/>
-            <a:ext cx="5074920" cy="530352"/>
+            <a:off x="749808" y="1261872"/>
+            <a:ext cx="5074920" cy="457200"/>
           </a:xfrm>
           <a:prstGeom prst="roundRect">
             <a:avLst/>
@@ -17737,8 +17742,8 @@
         </p:nvSpPr>
         <p:spPr>
           <a:xfrm>
-            <a:off x="841247" y="1380744"/>
-            <a:ext cx="292608" cy="320040"/>
+            <a:off x="841247" y="1316736"/>
+            <a:ext cx="292608" cy="292608"/>
           </a:xfrm>
           <a:prstGeom prst="rect">
             <a:avLst/>
@@ -17763,7 +17768,7 @@
               </a:spcAft>
             </a:pPr>
             <a:r>
-              <a:rPr sz="1400" b="1">
+              <a:rPr sz="1300" b="1">
                 <a:solidFill>
                   <a:srgbClr val="2E8555"/>
                 </a:solidFill>
@@ -17782,8 +17787,8 @@
         </p:nvSpPr>
         <p:spPr>
           <a:xfrm>
-            <a:off x="1225295" y="1380744"/>
-            <a:ext cx="4407408" cy="320040"/>
+            <a:off x="1225295" y="1316736"/>
+            <a:ext cx="4407408" cy="292608"/>
           </a:xfrm>
           <a:prstGeom prst="rect">
             <a:avLst/>
@@ -17808,7 +17813,7 @@
               </a:spcAft>
             </a:pPr>
             <a:r>
-              <a:rPr sz="900" b="1">
+              <a:rPr sz="800" b="1">
                 <a:solidFill>
                   <a:srgbClr val="193247"/>
                 </a:solidFill>
@@ -17827,8 +17832,8 @@
         </p:nvSpPr>
         <p:spPr>
           <a:xfrm>
-            <a:off x="6236208" y="1307592"/>
-            <a:ext cx="5074920" cy="530352"/>
+            <a:off x="6236208" y="1261872"/>
+            <a:ext cx="5074920" cy="457200"/>
           </a:xfrm>
           <a:prstGeom prst="roundRect">
             <a:avLst/>
@@ -17872,8 +17877,8 @@
         </p:nvSpPr>
         <p:spPr>
           <a:xfrm>
-            <a:off x="6327648" y="1380744"/>
-            <a:ext cx="292608" cy="320040"/>
+            <a:off x="6327648" y="1316736"/>
+            <a:ext cx="292608" cy="292608"/>
           </a:xfrm>
           <a:prstGeom prst="rect">
             <a:avLst/>
@@ -17898,7 +17903,7 @@
               </a:spcAft>
             </a:pPr>
             <a:r>
-              <a:rPr sz="1400" b="1">
+              <a:rPr sz="1300" b="1">
                 <a:solidFill>
                   <a:srgbClr val="2E8555"/>
                 </a:solidFill>
@@ -17917,8 +17922,8 @@
         </p:nvSpPr>
         <p:spPr>
           <a:xfrm>
-            <a:off x="6711696" y="1380744"/>
-            <a:ext cx="4407408" cy="320040"/>
+            <a:off x="6711696" y="1316736"/>
+            <a:ext cx="4407408" cy="292608"/>
           </a:xfrm>
           <a:prstGeom prst="rect">
             <a:avLst/>
@@ -17943,13 +17948,13 @@
               </a:spcAft>
             </a:pPr>
             <a:r>
-              <a:rPr sz="900" b="1">
+              <a:rPr sz="800" b="1">
                 <a:solidFill>
                   <a:srgbClr val="193247"/>
                 </a:solidFill>
                 <a:latin typeface="Noto Sans CJK TC"/>
               </a:rPr>
-              <a:t>KB Bridge 可發送 A2A job，Anritsu 回傳 taskId</a:t>
+              <a:t>KM Bridge 可發送 A2A job，Anritsu 回傳 context_id 與 a2a_task_id</a:t>
             </a:r>
           </a:p>
         </p:txBody>
@@ -17962,8 +17967,8 @@
         </p:nvSpPr>
         <p:spPr>
           <a:xfrm>
-            <a:off x="749808" y="2057400"/>
-            <a:ext cx="5074920" cy="530352"/>
+            <a:off x="749808" y="1901952"/>
+            <a:ext cx="5074920" cy="457200"/>
           </a:xfrm>
           <a:prstGeom prst="roundRect">
             <a:avLst/>
@@ -18007,8 +18012,8 @@
         </p:nvSpPr>
         <p:spPr>
           <a:xfrm>
-            <a:off x="841247" y="2130552"/>
-            <a:ext cx="292608" cy="320040"/>
+            <a:off x="841247" y="1956816"/>
+            <a:ext cx="292608" cy="292608"/>
           </a:xfrm>
           <a:prstGeom prst="rect">
             <a:avLst/>
@@ -18033,7 +18038,7 @@
               </a:spcAft>
             </a:pPr>
             <a:r>
-              <a:rPr sz="1400" b="1">
+              <a:rPr sz="1300" b="1">
                 <a:solidFill>
                   <a:srgbClr val="2E8555"/>
                 </a:solidFill>
@@ -18052,8 +18057,8 @@
         </p:nvSpPr>
         <p:spPr>
           <a:xfrm>
-            <a:off x="1225295" y="2130552"/>
-            <a:ext cx="4407408" cy="320040"/>
+            <a:off x="1225295" y="1956816"/>
+            <a:ext cx="4407408" cy="292608"/>
           </a:xfrm>
           <a:prstGeom prst="rect">
             <a:avLst/>
@@ -18078,7 +18083,7 @@
               </a:spcAft>
             </a:pPr>
             <a:r>
-              <a:rPr sz="900" b="1">
+              <a:rPr sz="800" b="1">
                 <a:solidFill>
                   <a:srgbClr val="193247"/>
                 </a:solidFill>
@@ -18097,8 +18102,8 @@
         </p:nvSpPr>
         <p:spPr>
           <a:xfrm>
-            <a:off x="6236208" y="2057400"/>
-            <a:ext cx="5074920" cy="530352"/>
+            <a:off x="6236208" y="1901952"/>
+            <a:ext cx="5074920" cy="457200"/>
           </a:xfrm>
           <a:prstGeom prst="roundRect">
             <a:avLst/>
@@ -18142,8 +18147,8 @@
         </p:nvSpPr>
         <p:spPr>
           <a:xfrm>
-            <a:off x="6327648" y="2130552"/>
-            <a:ext cx="292608" cy="320040"/>
+            <a:off x="6327648" y="1956816"/>
+            <a:ext cx="292608" cy="292608"/>
           </a:xfrm>
           <a:prstGeom prst="rect">
             <a:avLst/>
@@ -18168,7 +18173,7 @@
               </a:spcAft>
             </a:pPr>
             <a:r>
-              <a:rPr sz="1400" b="1">
+              <a:rPr sz="1300" b="1">
                 <a:solidFill>
                   <a:srgbClr val="2E8555"/>
                 </a:solidFill>
@@ -18187,8 +18192,8 @@
         </p:nvSpPr>
         <p:spPr>
           <a:xfrm>
-            <a:off x="6711696" y="2130552"/>
-            <a:ext cx="4407408" cy="320040"/>
+            <a:off x="6711696" y="1956816"/>
+            <a:ext cx="4407408" cy="292608"/>
           </a:xfrm>
           <a:prstGeom prst="rect">
             <a:avLst/>
@@ -18213,13 +18218,13 @@
               </a:spcAft>
             </a:pPr>
             <a:r>
-              <a:rPr sz="900" b="1">
+              <a:rPr sz="800" b="1">
                 <a:solidFill>
                   <a:srgbClr val="193247"/>
                 </a:solidFill>
                 <a:latin typeface="Noto Sans CJK TC"/>
               </a:rPr>
-              <a:t>dry-run、真實測試、取消、timeout、failed 都有明確狀態</a:t>
+              <a:t>KM 可隨時 submit；busy 時可 queued 或以穩定 reason rejected</a:t>
             </a:r>
           </a:p>
         </p:txBody>
@@ -18232,8 +18237,8 @@
         </p:nvSpPr>
         <p:spPr>
           <a:xfrm>
-            <a:off x="749808" y="2807208"/>
-            <a:ext cx="5074920" cy="530352"/>
+            <a:off x="749808" y="2542032"/>
+            <a:ext cx="5074920" cy="457200"/>
           </a:xfrm>
           <a:prstGeom prst="roundRect">
             <a:avLst/>
@@ -18277,8 +18282,8 @@
         </p:nvSpPr>
         <p:spPr>
           <a:xfrm>
-            <a:off x="841247" y="2880360"/>
-            <a:ext cx="292608" cy="320040"/>
+            <a:off x="841247" y="2596896"/>
+            <a:ext cx="292608" cy="292608"/>
           </a:xfrm>
           <a:prstGeom prst="rect">
             <a:avLst/>
@@ -18303,7 +18308,7 @@
               </a:spcAft>
             </a:pPr>
             <a:r>
-              <a:rPr sz="1400" b="1">
+              <a:rPr sz="1300" b="1">
                 <a:solidFill>
                   <a:srgbClr val="2E8555"/>
                 </a:solidFill>
@@ -18322,8 +18327,8 @@
         </p:nvSpPr>
         <p:spPr>
           <a:xfrm>
-            <a:off x="1225295" y="2880360"/>
-            <a:ext cx="4407408" cy="320040"/>
+            <a:off x="1225295" y="2596896"/>
+            <a:ext cx="4407408" cy="292608"/>
           </a:xfrm>
           <a:prstGeom prst="rect">
             <a:avLst/>
@@ -18348,13 +18353,13 @@
               </a:spcAft>
             </a:pPr>
             <a:r>
-              <a:rPr sz="900" b="1">
+              <a:rPr sz="800" b="1">
                 <a:solidFill>
                   <a:srgbClr val="193247"/>
                 </a:solidFill>
                 <a:latin typeface="Noto Sans CJK TC"/>
               </a:rPr>
-              <a:t>run_id、A2A taskId、KB task_id、file_hash 可相互追蹤</a:t>
+              <a:t>context_id、a2a_task_id、run_id、ingest_task_id 可持久追蹤</a:t>
             </a:r>
           </a:p>
         </p:txBody>
@@ -18367,8 +18372,8 @@
         </p:nvSpPr>
         <p:spPr>
           <a:xfrm>
-            <a:off x="6236208" y="2807208"/>
-            <a:ext cx="5074920" cy="530352"/>
+            <a:off x="6236208" y="2542032"/>
+            <a:ext cx="5074920" cy="457200"/>
           </a:xfrm>
           <a:prstGeom prst="roundRect">
             <a:avLst/>
@@ -18412,8 +18417,8 @@
         </p:nvSpPr>
         <p:spPr>
           <a:xfrm>
-            <a:off x="6327648" y="2880360"/>
-            <a:ext cx="292608" cy="320040"/>
+            <a:off x="6327648" y="2596896"/>
+            <a:ext cx="292608" cy="292608"/>
           </a:xfrm>
           <a:prstGeom prst="rect">
             <a:avLst/>
@@ -18438,7 +18443,7 @@
               </a:spcAft>
             </a:pPr>
             <a:r>
-              <a:rPr sz="1400" b="1">
+              <a:rPr sz="1300" b="1">
                 <a:solidFill>
                   <a:srgbClr val="2E8555"/>
                 </a:solidFill>
@@ -18457,8 +18462,8 @@
         </p:nvSpPr>
         <p:spPr>
           <a:xfrm>
-            <a:off x="6711696" y="2880360"/>
-            <a:ext cx="4407408" cy="320040"/>
+            <a:off x="6711696" y="2596896"/>
+            <a:ext cx="4407408" cy="292608"/>
           </a:xfrm>
           <a:prstGeom prst="rect">
             <a:avLst/>
@@ -18483,7 +18488,7 @@
               </a:spcAft>
             </a:pPr>
             <a:r>
-              <a:rPr sz="900" b="1">
+              <a:rPr sz="800" b="1">
                 <a:solidFill>
                   <a:srgbClr val="193247"/>
                 </a:solidFill>
@@ -18502,8 +18507,8 @@
         </p:nvSpPr>
         <p:spPr>
           <a:xfrm>
-            <a:off x="749808" y="3557015"/>
-            <a:ext cx="5074920" cy="530352"/>
+            <a:off x="749808" y="3182111"/>
+            <a:ext cx="5074920" cy="457200"/>
           </a:xfrm>
           <a:prstGeom prst="roundRect">
             <a:avLst/>
@@ -18547,8 +18552,8 @@
         </p:nvSpPr>
         <p:spPr>
           <a:xfrm>
-            <a:off x="841247" y="3630168"/>
-            <a:ext cx="292608" cy="320040"/>
+            <a:off x="841247" y="3236975"/>
+            <a:ext cx="292608" cy="292608"/>
           </a:xfrm>
           <a:prstGeom prst="rect">
             <a:avLst/>
@@ -18573,7 +18578,7 @@
               </a:spcAft>
             </a:pPr>
             <a:r>
-              <a:rPr sz="1400" b="1">
+              <a:rPr sz="1300" b="1">
                 <a:solidFill>
                   <a:srgbClr val="2E8555"/>
                 </a:solidFill>
@@ -18592,8 +18597,8 @@
         </p:nvSpPr>
         <p:spPr>
           <a:xfrm>
-            <a:off x="1225295" y="3630168"/>
-            <a:ext cx="4407408" cy="320040"/>
+            <a:off x="1225295" y="3236975"/>
+            <a:ext cx="4407408" cy="292608"/>
           </a:xfrm>
           <a:prstGeom prst="rect">
             <a:avLst/>
@@ -18618,7 +18623,7 @@
               </a:spcAft>
             </a:pPr>
             <a:r>
-              <a:rPr sz="900" b="1">
+              <a:rPr sz="800" b="1">
                 <a:solidFill>
                   <a:srgbClr val="193247"/>
                 </a:solidFill>
@@ -18637,8 +18642,8 @@
         </p:nvSpPr>
         <p:spPr>
           <a:xfrm>
-            <a:off x="6236208" y="3557015"/>
-            <a:ext cx="5074920" cy="530352"/>
+            <a:off x="6236208" y="3182111"/>
+            <a:ext cx="5074920" cy="457200"/>
           </a:xfrm>
           <a:prstGeom prst="roundRect">
             <a:avLst/>
@@ -18682,8 +18687,8 @@
         </p:nvSpPr>
         <p:spPr>
           <a:xfrm>
-            <a:off x="6327648" y="3630168"/>
-            <a:ext cx="292608" cy="320040"/>
+            <a:off x="6327648" y="3236975"/>
+            <a:ext cx="292608" cy="292608"/>
           </a:xfrm>
           <a:prstGeom prst="rect">
             <a:avLst/>
@@ -18708,7 +18713,7 @@
               </a:spcAft>
             </a:pPr>
             <a:r>
-              <a:rPr sz="1400" b="1">
+              <a:rPr sz="1300" b="1">
                 <a:solidFill>
                   <a:srgbClr val="2E8555"/>
                 </a:solidFill>
@@ -18727,8 +18732,8 @@
         </p:nvSpPr>
         <p:spPr>
           <a:xfrm>
-            <a:off x="6711696" y="3630168"/>
-            <a:ext cx="4407408" cy="320040"/>
+            <a:off x="6711696" y="3236975"/>
+            <a:ext cx="4407408" cy="292608"/>
           </a:xfrm>
           <a:prstGeom prst="rect">
             <a:avLst/>
@@ -18753,13 +18758,13 @@
               </a:spcAft>
             </a:pPr>
             <a:r>
-              <a:rPr sz="900" b="1">
+              <a:rPr sz="800" b="1">
                 <a:solidFill>
                   <a:srgbClr val="193247"/>
                 </a:solidFill>
                 <a:latin typeface="Noto Sans CJK TC"/>
               </a:rPr>
-              <a:t>Neo4j 與 Qdrant 都完成後才回報攝入 completed</a:t>
+              <a:t>test_status、report_status、ingest_status 分離；A2A completed 不混同 ingest completed</a:t>
             </a:r>
           </a:p>
         </p:txBody>
@@ -18772,8 +18777,8 @@
         </p:nvSpPr>
         <p:spPr>
           <a:xfrm>
-            <a:off x="749808" y="4306824"/>
-            <a:ext cx="5074920" cy="530352"/>
+            <a:off x="749808" y="3822191"/>
+            <a:ext cx="5074920" cy="457200"/>
           </a:xfrm>
           <a:prstGeom prst="roundRect">
             <a:avLst/>
@@ -18817,8 +18822,8 @@
         </p:nvSpPr>
         <p:spPr>
           <a:xfrm>
-            <a:off x="841247" y="4379976"/>
-            <a:ext cx="292608" cy="320040"/>
+            <a:off x="841247" y="3877055"/>
+            <a:ext cx="292608" cy="292608"/>
           </a:xfrm>
           <a:prstGeom prst="rect">
             <a:avLst/>
@@ -18843,7 +18848,7 @@
               </a:spcAft>
             </a:pPr>
             <a:r>
-              <a:rPr sz="1400" b="1">
+              <a:rPr sz="1300" b="1">
                 <a:solidFill>
                   <a:srgbClr val="2E8555"/>
                 </a:solidFill>
@@ -18862,8 +18867,8 @@
         </p:nvSpPr>
         <p:spPr>
           <a:xfrm>
-            <a:off x="1225295" y="4379976"/>
-            <a:ext cx="4407408" cy="320040"/>
+            <a:off x="1225295" y="3877055"/>
+            <a:ext cx="4407408" cy="292608"/>
           </a:xfrm>
           <a:prstGeom prst="rect">
             <a:avLst/>
@@ -18888,7 +18893,7 @@
               </a:spcAft>
             </a:pPr>
             <a:r>
-              <a:rPr sz="900" b="1">
+              <a:rPr sz="800" b="1">
                 <a:solidFill>
                   <a:srgbClr val="193247"/>
                 </a:solidFill>
@@ -18907,8 +18912,8 @@
         </p:nvSpPr>
         <p:spPr>
           <a:xfrm>
-            <a:off x="6236208" y="4306824"/>
-            <a:ext cx="5074920" cy="530352"/>
+            <a:off x="6236208" y="3822191"/>
+            <a:ext cx="5074920" cy="457200"/>
           </a:xfrm>
           <a:prstGeom prst="roundRect">
             <a:avLst/>
@@ -18952,8 +18957,8 @@
         </p:nvSpPr>
         <p:spPr>
           <a:xfrm>
-            <a:off x="6327648" y="4379976"/>
-            <a:ext cx="292608" cy="320040"/>
+            <a:off x="6327648" y="3877055"/>
+            <a:ext cx="292608" cy="292608"/>
           </a:xfrm>
           <a:prstGeom prst="rect">
             <a:avLst/>
@@ -18978,7 +18983,7 @@
               </a:spcAft>
             </a:pPr>
             <a:r>
-              <a:rPr sz="1400" b="1">
+              <a:rPr sz="1300" b="1">
                 <a:solidFill>
                   <a:srgbClr val="2E8555"/>
                 </a:solidFill>
@@ -18997,8 +19002,8 @@
         </p:nvSpPr>
         <p:spPr>
           <a:xfrm>
-            <a:off x="6711696" y="4379976"/>
-            <a:ext cx="4407408" cy="320040"/>
+            <a:off x="6711696" y="3877055"/>
+            <a:ext cx="4407408" cy="292608"/>
           </a:xfrm>
           <a:prstGeom prst="rect">
             <a:avLst/>
@@ -19023,13 +19028,13 @@
               </a:spcAft>
             </a:pPr>
             <a:r>
-              <a:rPr sz="900" b="1">
+              <a:rPr sz="800" b="1">
                 <a:solidFill>
                   <a:srgbClr val="193247"/>
                 </a:solidFill>
                 <a:latin typeface="Noto Sans CJK TC"/>
               </a:rPr>
-              <a:t>KB 原有 chat、search、ingest 與服務 health check 無回歸</a:t>
+              <a:t>手動測試及 KM chat/search/ingest/health 在 A2A 關閉或故障時仍正常</a:t>
             </a:r>
           </a:p>
         </p:txBody>
@@ -19037,6 +19042,276 @@
       <p:sp>
         <p:nvSpPr>
           <p:cNvPr id="38" name="Rounded Rectangle 37"/>
+          <p:cNvSpPr/>
+          <p:nvPr/>
+        </p:nvSpPr>
+        <p:spPr>
+          <a:xfrm>
+            <a:off x="749808" y="4462272"/>
+            <a:ext cx="5074920" cy="457200"/>
+          </a:xfrm>
+          <a:prstGeom prst="roundRect">
+            <a:avLst/>
+          </a:prstGeom>
+          <a:solidFill>
+            <a:srgbClr val="E8F6ED"/>
+          </a:solidFill>
+          <a:ln w="10160">
+            <a:solidFill>
+              <a:srgbClr val="2E8555"/>
+            </a:solidFill>
+          </a:ln>
+        </p:spPr>
+        <p:style>
+          <a:lnRef idx="1">
+            <a:schemeClr val="accent1"/>
+          </a:lnRef>
+          <a:fillRef idx="3">
+            <a:schemeClr val="accent1"/>
+          </a:fillRef>
+          <a:effectRef idx="2">
+            <a:schemeClr val="accent1"/>
+          </a:effectRef>
+          <a:fontRef idx="minor">
+            <a:schemeClr val="lt1"/>
+          </a:fontRef>
+        </p:style>
+        <p:txBody>
+          <a:bodyPr rtlCol="0" anchor="ctr"/>
+          <a:lstStyle/>
+          <a:p>
+            <a:pPr algn="ctr"/>
+          </a:p>
+        </p:txBody>
+      </p:sp>
+      <p:sp>
+        <p:nvSpPr>
+          <p:cNvPr id="39" name="TextBox 38"/>
+          <p:cNvSpPr txBox="1"/>
+          <p:nvPr/>
+        </p:nvSpPr>
+        <p:spPr>
+          <a:xfrm>
+            <a:off x="841247" y="4517136"/>
+            <a:ext cx="292608" cy="292608"/>
+          </a:xfrm>
+          <a:prstGeom prst="rect">
+            <a:avLst/>
+          </a:prstGeom>
+          <a:noFill/>
+        </p:spPr>
+        <p:txBody>
+          <a:bodyPr wrap="square" anchor="ctr" lIns="88900" rIns="88900" tIns="38100" bIns="38100">
+            <a:normAutofit/>
+          </a:bodyPr>
+          <a:lstStyle/>
+          <a:p>
+            <a:pPr algn="ctr">
+              <a:lnSpc>
+                <a:spcPct val="100000"/>
+              </a:lnSpc>
+              <a:spcBef>
+                <a:spcPts val="0"/>
+              </a:spcBef>
+              <a:spcAft>
+                <a:spcPts val="0"/>
+              </a:spcAft>
+            </a:pPr>
+            <a:r>
+              <a:rPr sz="1300" b="1">
+                <a:solidFill>
+                  <a:srgbClr val="2E8555"/>
+                </a:solidFill>
+                <a:latin typeface="Noto Sans CJK TC"/>
+              </a:rPr>
+              <a:t>✓</a:t>
+            </a:r>
+          </a:p>
+        </p:txBody>
+      </p:sp>
+      <p:sp>
+        <p:nvSpPr>
+          <p:cNvPr id="40" name="TextBox 39"/>
+          <p:cNvSpPr txBox="1"/>
+          <p:nvPr/>
+        </p:nvSpPr>
+        <p:spPr>
+          <a:xfrm>
+            <a:off x="1225295" y="4517136"/>
+            <a:ext cx="4407408" cy="292608"/>
+          </a:xfrm>
+          <a:prstGeom prst="rect">
+            <a:avLst/>
+          </a:prstGeom>
+          <a:noFill/>
+        </p:spPr>
+        <p:txBody>
+          <a:bodyPr wrap="square" anchor="ctr" lIns="88900" rIns="88900" tIns="38100" bIns="38100">
+            <a:normAutofit/>
+          </a:bodyPr>
+          <a:lstStyle/>
+          <a:p>
+            <a:pPr algn="l">
+              <a:lnSpc>
+                <a:spcPct val="100000"/>
+              </a:lnSpc>
+              <a:spcBef>
+                <a:spcPts val="0"/>
+              </a:spcBef>
+              <a:spcAft>
+                <a:spcPts val="0"/>
+              </a:spcAft>
+            </a:pPr>
+            <a:r>
+              <a:rPr sz="800" b="1">
+                <a:solidFill>
+                  <a:srgbClr val="193247"/>
+                </a:solidFill>
+                <a:latin typeface="Noto Sans CJK TC"/>
+              </a:rPr>
+              <a:t>Amarisoft 依相同契約獨立部署，使用不同 endpoint、credential 與 queue</a:t>
+            </a:r>
+          </a:p>
+        </p:txBody>
+      </p:sp>
+      <p:sp>
+        <p:nvSpPr>
+          <p:cNvPr id="41" name="Rounded Rectangle 40"/>
+          <p:cNvSpPr/>
+          <p:nvPr/>
+        </p:nvSpPr>
+        <p:spPr>
+          <a:xfrm>
+            <a:off x="6236208" y="4462272"/>
+            <a:ext cx="5074920" cy="457200"/>
+          </a:xfrm>
+          <a:prstGeom prst="roundRect">
+            <a:avLst/>
+          </a:prstGeom>
+          <a:solidFill>
+            <a:srgbClr val="E8F6ED"/>
+          </a:solidFill>
+          <a:ln w="10160">
+            <a:solidFill>
+              <a:srgbClr val="2E8555"/>
+            </a:solidFill>
+          </a:ln>
+        </p:spPr>
+        <p:style>
+          <a:lnRef idx="1">
+            <a:schemeClr val="accent1"/>
+          </a:lnRef>
+          <a:fillRef idx="3">
+            <a:schemeClr val="accent1"/>
+          </a:fillRef>
+          <a:effectRef idx="2">
+            <a:schemeClr val="accent1"/>
+          </a:effectRef>
+          <a:fontRef idx="minor">
+            <a:schemeClr val="lt1"/>
+          </a:fontRef>
+        </p:style>
+        <p:txBody>
+          <a:bodyPr rtlCol="0" anchor="ctr"/>
+          <a:lstStyle/>
+          <a:p>
+            <a:pPr algn="ctr"/>
+          </a:p>
+        </p:txBody>
+      </p:sp>
+      <p:sp>
+        <p:nvSpPr>
+          <p:cNvPr id="42" name="TextBox 41"/>
+          <p:cNvSpPr txBox="1"/>
+          <p:nvPr/>
+        </p:nvSpPr>
+        <p:spPr>
+          <a:xfrm>
+            <a:off x="6327648" y="4517136"/>
+            <a:ext cx="292608" cy="292608"/>
+          </a:xfrm>
+          <a:prstGeom prst="rect">
+            <a:avLst/>
+          </a:prstGeom>
+          <a:noFill/>
+        </p:spPr>
+        <p:txBody>
+          <a:bodyPr wrap="square" anchor="ctr" lIns="88900" rIns="88900" tIns="38100" bIns="38100">
+            <a:normAutofit/>
+          </a:bodyPr>
+          <a:lstStyle/>
+          <a:p>
+            <a:pPr algn="ctr">
+              <a:lnSpc>
+                <a:spcPct val="100000"/>
+              </a:lnSpc>
+              <a:spcBef>
+                <a:spcPts val="0"/>
+              </a:spcBef>
+              <a:spcAft>
+                <a:spcPts val="0"/>
+              </a:spcAft>
+            </a:pPr>
+            <a:r>
+              <a:rPr sz="1300" b="1">
+                <a:solidFill>
+                  <a:srgbClr val="2E8555"/>
+                </a:solidFill>
+                <a:latin typeface="Noto Sans CJK TC"/>
+              </a:rPr>
+              <a:t>✓</a:t>
+            </a:r>
+          </a:p>
+        </p:txBody>
+      </p:sp>
+      <p:sp>
+        <p:nvSpPr>
+          <p:cNvPr id="43" name="TextBox 42"/>
+          <p:cNvSpPr txBox="1"/>
+          <p:nvPr/>
+        </p:nvSpPr>
+        <p:spPr>
+          <a:xfrm>
+            <a:off x="6711696" y="4517136"/>
+            <a:ext cx="4407408" cy="292608"/>
+          </a:xfrm>
+          <a:prstGeom prst="rect">
+            <a:avLst/>
+          </a:prstGeom>
+          <a:noFill/>
+        </p:spPr>
+        <p:txBody>
+          <a:bodyPr wrap="square" anchor="ctr" lIns="88900" rIns="88900" tIns="38100" bIns="38100">
+            <a:normAutofit/>
+          </a:bodyPr>
+          <a:lstStyle/>
+          <a:p>
+            <a:pPr algn="l">
+              <a:lnSpc>
+                <a:spcPct val="100000"/>
+              </a:lnSpc>
+              <a:spcBef>
+                <a:spcPts val="0"/>
+              </a:spcBef>
+              <a:spcAft>
+                <a:spcPts val="0"/>
+              </a:spcAft>
+            </a:pPr>
+            <a:r>
+              <a:rPr sz="800" b="1">
+                <a:solidFill>
+                  <a:srgbClr val="193247"/>
+                </a:solidFill>
+                <a:latin typeface="Noto Sans CJK TC"/>
+              </a:rPr>
+              <a:t>Anritsu／Amarisoft 並行時不交叉鎖定儀器，也不混用 run 或攝入資料</a:t>
+            </a:r>
+          </a:p>
+        </p:txBody>
+      </p:sp>
+      <p:sp>
+        <p:nvSpPr>
+          <p:cNvPr id="44" name="Rounded Rectangle 43"/>
           <p:cNvSpPr/>
           <p:nvPr/>
         </p:nvSpPr>
@@ -19081,7 +19356,7 @@
       </p:sp>
       <p:sp>
         <p:nvSpPr>
-          <p:cNvPr id="39" name="TextBox 38"/>
+          <p:cNvPr id="45" name="TextBox 44"/>
           <p:cNvSpPr txBox="1"/>
           <p:nvPr/>
         </p:nvSpPr>
@@ -19542,19 +19817,19 @@
               </a:spcAft>
             </a:pPr>
             <a:r>
-              <a:rPr sz="1200" b="0">
+              <a:rPr sz="1000" b="0">
                 <a:solidFill>
                   <a:srgbClr val="193247"/>
                 </a:solidFill>
                 <a:latin typeface="Noto Sans CJK TC"/>
               </a:rPr>
-              <a:t>1. 建立 Python venv 與 A2A SDK
-2. 寫 Agent Card 與 A2A server
-3. 定義固定 job schema / profile
-4. 包裝既有儀器控制函式
-5. 建立 task state / audit
-6. 接回既有 Excel uploader
-7. 用 dry-run 驗證整條鏈路</a:t>
+              <a:t>1. 建立獨立 venv、sidecar 與 feature flag
+2. 寫 Agent Card / A2A server；先接 mock executor
+3. 定義 allowlisted job schema / profile
+4. 實作 queue / reject、lock、timeout / cancel
+5. 持久化四個 correlation ID 與三種 status
+6. 包裝既有控制函式與 Excel uploader
+7. mock → dry-run → 單一真實 profile</a:t>
             </a:r>
           </a:p>
         </p:txBody>
@@ -19795,8 +20070,8 @@
         </p:nvSpPr>
         <p:spPr>
           <a:xfrm>
-            <a:off x="749808" y="6035040"/>
-            <a:ext cx="10652760" cy="256032"/>
+            <a:off x="749808" y="5961888"/>
+            <a:ext cx="10652760" cy="384048"/>
           </a:xfrm>
           <a:prstGeom prst="rect">
             <a:avLst/>
@@ -19821,13 +20096,13 @@
               </a:spcAft>
             </a:pPr>
             <a:r>
-              <a:rPr sz="1100" b="1">
+              <a:rPr sz="1000" b="1">
                 <a:solidFill>
                   <a:srgbClr val="0B1F33"/>
                 </a:solidFill>
                 <a:latin typeface="Noto Sans CJK TC"/>
               </a:rPr>
-              <a:t>完成後先提交 Agent Card、job schema、測試 log 與 dry-run 結果，再進入真實儀器測試。</a:t>
+              <a:t>先提交 Agent Card、schema、mock / dry-run log、queue/reject 與 rollback 證據；主 Agent 核准後才開放真實儀器。</a:t>
             </a:r>
           </a:p>
         </p:txBody>
@@ -20625,13 +20900,13 @@
               </a:spcAft>
             </a:pPr>
             <a:r>
-              <a:rPr sz="1300" b="1">
+              <a:rPr sz="1200" b="1">
                 <a:solidFill>
                   <a:srgbClr val="0B1F33"/>
                 </a:solidFill>
                 <a:latin typeface="Noto Sans CJK TC"/>
               </a:rPr>
-              <a:t>推薦鏈路：KB Agent → A2A → Anritsu Agent → MCP / Instrument → Excel → 既有 KB HTTP ingest</a:t>
+              <a:t>推薦鏈路：KM Control Plane → A2A → Test Execution Plane → MCP / Instrument → Excel → 既有 KB HTTP ingest</a:t>
             </a:r>
           </a:p>
         </p:txBody>
@@ -20745,7 +21020,7 @@
                 </a:solidFill>
                 <a:latin typeface="Noto Sans CJK TC"/>
               </a:rPr>
-              <a:t>目標架構：只增加出站委派橋接層</a:t>
+              <a:t>目標架構：KM 中央協調，多測試 Agent 獨立執行</a:t>
             </a:r>
           </a:p>
         </p:txBody>
@@ -20790,7 +21065,7 @@
                 </a:solidFill>
                 <a:latin typeface="Noto Sans CJK TC"/>
               </a:rPr>
-              <a:t>KB 核心服務保持原樣，Anritsu 保持儀器控制權</a:t>
+              <a:t>邏輯上是父子階層；runtime、憑證、queue 與儀器控制彼此隔離</a:t>
             </a:r>
           </a:p>
         </p:txBody>
@@ -21151,7 +21426,7 @@
                 </a:solidFill>
                 <a:latin typeface="Noto Sans CJK TC"/>
               </a:rPr>
-              <a:t>KB Agent</a:t>
+              <a:t>KM Central Agent</a:t>
             </a:r>
           </a:p>
         </p:txBody>
@@ -21190,14 +21465,14 @@
               </a:spcAft>
             </a:pPr>
             <a:r>
-              <a:rPr sz="1000" b="0">
+              <a:rPr sz="900" b="0">
                 <a:solidFill>
                   <a:srgbClr val="193247"/>
                 </a:solidFill>
                 <a:latin typeface="Noto Sans CJK TC"/>
               </a:rPr>
-              <a:t>OpenClaw / Agent
-決定是否委派</a:t>
+              <a:t>OpenClaw Orchestrator
+策略、批准、派工與追蹤</a:t>
             </a:r>
           </a:p>
         </p:txBody>
@@ -21326,14 +21601,14 @@
               </a:spcAft>
             </a:pPr>
             <a:r>
-              <a:rPr sz="1000" b="0">
+              <a:rPr sz="900" b="0">
                 <a:solidFill>
                   <a:srgbClr val="193247"/>
                 </a:solidFill>
                 <a:latin typeface="Noto Sans CJK TC"/>
               </a:rPr>
-              <a:t>獨立程序
-A2A Client</a:t>
+              <a:t>獨立程序／預設關閉
+outbound A2A Client</a:t>
             </a:r>
           </a:p>
         </p:txBody>
@@ -21346,8 +21621,8 @@
         </p:nvSpPr>
         <p:spPr>
           <a:xfrm>
-            <a:off x="8641080" y="1417320"/>
-            <a:ext cx="2971800" cy="1325880"/>
+            <a:off x="8641080" y="1143000"/>
+            <a:ext cx="2971800" cy="1097280"/>
           </a:xfrm>
           <a:prstGeom prst="roundRect">
             <a:avLst/>
@@ -21391,7 +21666,7 @@
         </p:nvSpPr>
         <p:spPr>
           <a:xfrm>
-            <a:off x="8732519" y="1508760"/>
+            <a:off x="8732519" y="1234440"/>
             <a:ext cx="2788920" cy="310896"/>
           </a:xfrm>
           <a:prstGeom prst="rect">
@@ -21417,13 +21692,13 @@
               </a:spcAft>
             </a:pPr>
             <a:r>
-              <a:rPr sz="1400" b="1">
+              <a:rPr sz="1200" b="1">
                 <a:solidFill>
                   <a:srgbClr val="C87512"/>
                 </a:solidFill>
                 <a:latin typeface="Noto Sans CJK TC"/>
               </a:rPr>
-              <a:t>Anritsu Agent</a:t>
+              <a:t>Anritsu Execution Plane</a:t>
             </a:r>
           </a:p>
         </p:txBody>
@@ -21436,8 +21711,8 @@
         </p:nvSpPr>
         <p:spPr>
           <a:xfrm>
-            <a:off x="8732519" y="1874519"/>
-            <a:ext cx="2788920" cy="795528"/>
+            <a:off x="8732519" y="1600200"/>
+            <a:ext cx="2788920" cy="566928"/>
           </a:xfrm>
           <a:prstGeom prst="rect">
             <a:avLst/>
@@ -21462,21 +21737,157 @@
               </a:spcAft>
             </a:pPr>
             <a:r>
-              <a:rPr sz="1000" b="0">
+              <a:rPr sz="900" b="0">
                 <a:solidFill>
                   <a:srgbClr val="193247"/>
                 </a:solidFill>
                 <a:latin typeface="Noto Sans CJK TC"/>
               </a:rPr>
-              <a:t>Windows 11
-A2A Server + test executor</a:t>
+              <a:t>獨立 Windows A2A Server
+儀器 lock + test executor</a:t>
+            </a:r>
+          </a:p>
+        </p:txBody>
+      </p:sp>
+      <p:sp>
+        <p:nvSpPr>
+          <p:cNvPr id="20" name="Rounded Rectangle 19"/>
+          <p:cNvSpPr/>
+          <p:nvPr/>
+        </p:nvSpPr>
+        <p:spPr>
+          <a:xfrm>
+            <a:off x="8641080" y="2468880"/>
+            <a:ext cx="2971800" cy="1097280"/>
+          </a:xfrm>
+          <a:prstGeom prst="roundRect">
+            <a:avLst/>
+          </a:prstGeom>
+          <a:solidFill>
+            <a:srgbClr val="E8F6ED"/>
+          </a:solidFill>
+          <a:ln w="17780">
+            <a:solidFill>
+              <a:srgbClr val="2E8555"/>
+            </a:solidFill>
+          </a:ln>
+        </p:spPr>
+        <p:style>
+          <a:lnRef idx="1">
+            <a:schemeClr val="accent1"/>
+          </a:lnRef>
+          <a:fillRef idx="3">
+            <a:schemeClr val="accent1"/>
+          </a:fillRef>
+          <a:effectRef idx="2">
+            <a:schemeClr val="accent1"/>
+          </a:effectRef>
+          <a:fontRef idx="minor">
+            <a:schemeClr val="lt1"/>
+          </a:fontRef>
+        </p:style>
+        <p:txBody>
+          <a:bodyPr rtlCol="0" anchor="ctr"/>
+          <a:lstStyle/>
+          <a:p>
+            <a:pPr algn="ctr"/>
+          </a:p>
+        </p:txBody>
+      </p:sp>
+      <p:sp>
+        <p:nvSpPr>
+          <p:cNvPr id="21" name="TextBox 20"/>
+          <p:cNvSpPr txBox="1"/>
+          <p:nvPr/>
+        </p:nvSpPr>
+        <p:spPr>
+          <a:xfrm>
+            <a:off x="8732519" y="2560320"/>
+            <a:ext cx="2788920" cy="310896"/>
+          </a:xfrm>
+          <a:prstGeom prst="rect">
+            <a:avLst/>
+          </a:prstGeom>
+          <a:noFill/>
+        </p:spPr>
+        <p:txBody>
+          <a:bodyPr wrap="square" anchor="ctr" lIns="88900" rIns="88900" tIns="38100" bIns="38100">
+            <a:normAutofit/>
+          </a:bodyPr>
+          <a:lstStyle/>
+          <a:p>
+            <a:pPr algn="l">
+              <a:lnSpc>
+                <a:spcPct val="100000"/>
+              </a:lnSpc>
+              <a:spcBef>
+                <a:spcPts val="0"/>
+              </a:spcBef>
+              <a:spcAft>
+                <a:spcPts val="0"/>
+              </a:spcAft>
+            </a:pPr>
+            <a:r>
+              <a:rPr sz="1200" b="1">
+                <a:solidFill>
+                  <a:srgbClr val="2E8555"/>
+                </a:solidFill>
+                <a:latin typeface="Noto Sans CJK TC"/>
+              </a:rPr>
+              <a:t>Amarisoft Execution Plane</a:t>
+            </a:r>
+          </a:p>
+        </p:txBody>
+      </p:sp>
+      <p:sp>
+        <p:nvSpPr>
+          <p:cNvPr id="22" name="TextBox 21"/>
+          <p:cNvSpPr txBox="1"/>
+          <p:nvPr/>
+        </p:nvSpPr>
+        <p:spPr>
+          <a:xfrm>
+            <a:off x="8732519" y="2926080"/>
+            <a:ext cx="2788920" cy="566928"/>
+          </a:xfrm>
+          <a:prstGeom prst="rect">
+            <a:avLst/>
+          </a:prstGeom>
+          <a:noFill/>
+        </p:spPr>
+        <p:txBody>
+          <a:bodyPr wrap="square" anchor="ctr" lIns="88900" rIns="88900" tIns="38100" bIns="38100">
+            <a:normAutofit/>
+          </a:bodyPr>
+          <a:lstStyle/>
+          <a:p>
+            <a:pPr algn="l">
+              <a:lnSpc>
+                <a:spcPct val="100000"/>
+              </a:lnSpc>
+              <a:spcBef>
+                <a:spcPts val="0"/>
+              </a:spcBef>
+              <a:spcAft>
+                <a:spcPts val="0"/>
+              </a:spcAft>
+            </a:pPr>
+            <a:r>
+              <a:rPr sz="900" b="0">
+                <a:solidFill>
+                  <a:srgbClr val="193247"/>
+                </a:solidFill>
+                <a:latin typeface="Noto Sans CJK TC"/>
+              </a:rPr>
+              <a:t>獨立 A2A Server／credential
+相同契約、不同能力與 queue</a:t>
             </a:r>
           </a:p>
         </p:txBody>
       </p:sp>
       <p:cxnSp>
         <p:nvCxnSpPr>
-          <p:cNvPr id="20" name="Connector 19"/>
+          <p:cNvPr id="23" name="Connector 22"/>
           <p:cNvCxnSpPr/>
           <p:nvPr/>
         </p:nvCxnSpPr>
@@ -21512,7 +21923,7 @@
       </p:cxnSp>
       <p:cxnSp>
         <p:nvCxnSpPr>
-          <p:cNvPr id="21" name="Connector 20"/>
+          <p:cNvPr id="24" name="Connector 23"/>
           <p:cNvCxnSpPr/>
           <p:nvPr/>
         </p:nvCxnSpPr>
@@ -21548,14 +21959,14 @@
       </p:cxnSp>
       <p:cxnSp>
         <p:nvCxnSpPr>
-          <p:cNvPr id="22" name="Connector 21"/>
+          <p:cNvPr id="25" name="Connector 24"/>
           <p:cNvCxnSpPr/>
           <p:nvPr/>
         </p:nvCxnSpPr>
         <p:spPr>
-          <a:xfrm>
-            <a:off x="8138160" y="2084831"/>
-            <a:ext cx="502920" cy="0"/>
+          <a:xfrm flipV="1">
+            <a:off x="8138160" y="1691640"/>
+            <a:ext cx="502920" cy="393191"/>
           </a:xfrm>
           <a:prstGeom prst="line">
             <a:avLst/>
@@ -21582,9 +21993,45 @@
           </a:fontRef>
         </p:style>
       </p:cxnSp>
-      <p:sp>
-        <p:nvSpPr>
-          <p:cNvPr id="23" name="TextBox 22"/>
+      <p:cxnSp>
+        <p:nvCxnSpPr>
+          <p:cNvPr id="26" name="Connector 25"/>
+          <p:cNvCxnSpPr/>
+          <p:nvPr/>
+        </p:nvCxnSpPr>
+        <p:spPr>
+          <a:xfrm>
+            <a:off x="8138160" y="2084831"/>
+            <a:ext cx="502920" cy="932689"/>
+          </a:xfrm>
+          <a:prstGeom prst="line">
+            <a:avLst/>
+          </a:prstGeom>
+          <a:ln w="25400">
+            <a:solidFill>
+              <a:srgbClr val="2E8555"/>
+            </a:solidFill>
+            <a:tailEnd type="triangle" w="sm" len="sm"/>
+          </a:ln>
+        </p:spPr>
+        <p:style>
+          <a:lnRef idx="2">
+            <a:schemeClr val="accent1"/>
+          </a:lnRef>
+          <a:fillRef idx="0">
+            <a:schemeClr val="accent1"/>
+          </a:fillRef>
+          <a:effectRef idx="1">
+            <a:schemeClr val="accent1"/>
+          </a:effectRef>
+          <a:fontRef idx="minor">
+            <a:schemeClr val="tx1"/>
+          </a:fontRef>
+        </p:style>
+      </p:cxnSp>
+      <p:sp>
+        <p:nvSpPr>
+          <p:cNvPr id="27" name="TextBox 26"/>
           <p:cNvSpPr txBox="1"/>
           <p:nvPr/>
         </p:nvSpPr>
@@ -21629,7 +22076,7 @@
       </p:sp>
       <p:sp>
         <p:nvSpPr>
-          <p:cNvPr id="24" name="TextBox 23"/>
+          <p:cNvPr id="28" name="TextBox 27"/>
           <p:cNvSpPr txBox="1"/>
           <p:nvPr/>
         </p:nvSpPr>
@@ -21674,7 +22121,7 @@
       </p:sp>
       <p:sp>
         <p:nvSpPr>
-          <p:cNvPr id="25" name="TextBox 24"/>
+          <p:cNvPr id="29" name="TextBox 28"/>
           <p:cNvSpPr txBox="1"/>
           <p:nvPr/>
         </p:nvSpPr>
@@ -21712,21 +22159,21 @@
                 </a:solidFill>
                 <a:latin typeface="Noto Sans CJK TC"/>
               </a:rPr>
-              <a:t>VPN</a:t>
-            </a:r>
-          </a:p>
-        </p:txBody>
-      </p:sp>
-      <p:sp>
-        <p:nvSpPr>
-          <p:cNvPr id="26" name="Rounded Rectangle 25"/>
+              <a:t>A2A</a:t>
+            </a:r>
+          </a:p>
+        </p:txBody>
+      </p:sp>
+      <p:sp>
+        <p:nvSpPr>
+          <p:cNvPr id="30" name="Rounded Rectangle 29"/>
           <p:cNvSpPr/>
           <p:nvPr/>
         </p:nvSpPr>
         <p:spPr>
           <a:xfrm>
-            <a:off x="8732520" y="3337560"/>
-            <a:ext cx="2514600" cy="1143000"/>
+            <a:off x="8732520" y="3886200"/>
+            <a:ext cx="2514600" cy="777240"/>
           </a:xfrm>
           <a:prstGeom prst="roundRect">
             <a:avLst/>
@@ -21764,13 +22211,13 @@
       </p:sp>
       <p:sp>
         <p:nvSpPr>
-          <p:cNvPr id="27" name="TextBox 26"/>
-          <p:cNvSpPr txBox="1"/>
-          <p:nvPr/>
-        </p:nvSpPr>
-        <p:spPr>
-          <a:xfrm>
-            <a:off x="8823960" y="3429000"/>
+          <p:cNvPr id="31" name="TextBox 30"/>
+          <p:cNvSpPr txBox="1"/>
+          <p:nvPr/>
+        </p:nvSpPr>
+        <p:spPr>
+          <a:xfrm>
+            <a:off x="8823960" y="3977639"/>
             <a:ext cx="2331720" cy="310896"/>
           </a:xfrm>
           <a:prstGeom prst="rect">
@@ -21796,7 +22243,7 @@
               </a:spcAft>
             </a:pPr>
             <a:r>
-              <a:rPr sz="1300" b="1">
+              <a:rPr sz="1200" b="1">
                 <a:solidFill>
                   <a:srgbClr val="B33A3A"/>
                 </a:solidFill>
@@ -21809,14 +22256,14 @@
       </p:sp>
       <p:sp>
         <p:nvSpPr>
-          <p:cNvPr id="28" name="TextBox 27"/>
-          <p:cNvSpPr txBox="1"/>
-          <p:nvPr/>
-        </p:nvSpPr>
-        <p:spPr>
-          <a:xfrm>
-            <a:off x="8823960" y="3794760"/>
-            <a:ext cx="2331720" cy="612648"/>
+          <p:cNvPr id="32" name="TextBox 31"/>
+          <p:cNvSpPr txBox="1"/>
+          <p:nvPr/>
+        </p:nvSpPr>
+        <p:spPr>
+          <a:xfrm>
+            <a:off x="8823960" y="4343400"/>
+            <a:ext cx="2331720" cy="246888"/>
           </a:xfrm>
           <a:prstGeom prst="rect">
             <a:avLst/>
@@ -21841,21 +22288,20 @@
               </a:spcAft>
             </a:pPr>
             <a:r>
-              <a:rPr sz="1000" b="0">
+              <a:rPr sz="800" b="0">
                 <a:solidFill>
                   <a:srgbClr val="193247"/>
                 </a:solidFill>
                 <a:latin typeface="Noto Sans CJK TC"/>
               </a:rPr>
-              <a:t>現有控制流程
-固定 profile 執行</a:t>
-            </a:r>
-          </a:p>
-        </p:txBody>
-      </p:sp>
-      <p:sp>
-        <p:nvSpPr>
-          <p:cNvPr id="29" name="Rounded Rectangle 28"/>
+              <a:t>各環境現有控制流程／固定 profile</a:t>
+            </a:r>
+          </a:p>
+        </p:txBody>
+      </p:sp>
+      <p:sp>
+        <p:nvSpPr>
+          <p:cNvPr id="33" name="Rounded Rectangle 32"/>
           <p:cNvSpPr/>
           <p:nvPr/>
         </p:nvSpPr>
@@ -21900,7 +22346,7 @@
       </p:sp>
       <p:sp>
         <p:nvSpPr>
-          <p:cNvPr id="30" name="TextBox 29"/>
+          <p:cNvPr id="34" name="TextBox 33"/>
           <p:cNvSpPr txBox="1"/>
           <p:nvPr/>
         </p:nvSpPr>
@@ -21945,7 +22391,7 @@
       </p:sp>
       <p:sp>
         <p:nvSpPr>
-          <p:cNvPr id="31" name="TextBox 30"/>
+          <p:cNvPr id="35" name="TextBox 34"/>
           <p:cNvSpPr txBox="1"/>
           <p:nvPr/>
         </p:nvSpPr>
@@ -21991,7 +22437,7 @@
       </p:sp>
       <p:sp>
         <p:nvSpPr>
-          <p:cNvPr id="32" name="Rounded Rectangle 31"/>
+          <p:cNvPr id="36" name="Rounded Rectangle 35"/>
           <p:cNvSpPr/>
           <p:nvPr/>
         </p:nvSpPr>
@@ -22036,7 +22482,7 @@
       </p:sp>
       <p:sp>
         <p:nvSpPr>
-          <p:cNvPr id="33" name="TextBox 32"/>
+          <p:cNvPr id="37" name="TextBox 36"/>
           <p:cNvSpPr txBox="1"/>
           <p:nvPr/>
         </p:nvSpPr>
@@ -22081,7 +22527,7 @@
       </p:sp>
       <p:sp>
         <p:nvSpPr>
-          <p:cNvPr id="34" name="TextBox 33"/>
+          <p:cNvPr id="38" name="TextBox 37"/>
           <p:cNvSpPr txBox="1"/>
           <p:nvPr/>
         </p:nvSpPr>
@@ -22126,7 +22572,7 @@
       </p:sp>
       <p:sp>
         <p:nvSpPr>
-          <p:cNvPr id="35" name="Rounded Rectangle 34"/>
+          <p:cNvPr id="39" name="Rounded Rectangle 38"/>
           <p:cNvSpPr/>
           <p:nvPr/>
         </p:nvSpPr>
@@ -22171,7 +22617,7 @@
       </p:sp>
       <p:sp>
         <p:nvSpPr>
-          <p:cNvPr id="36" name="TextBox 35"/>
+          <p:cNvPr id="40" name="TextBox 39"/>
           <p:cNvSpPr txBox="1"/>
           <p:nvPr/>
         </p:nvSpPr>
@@ -22216,7 +22662,7 @@
       </p:sp>
       <p:sp>
         <p:nvSpPr>
-          <p:cNvPr id="37" name="TextBox 36"/>
+          <p:cNvPr id="41" name="TextBox 40"/>
           <p:cNvSpPr txBox="1"/>
           <p:nvPr/>
         </p:nvSpPr>
@@ -22261,14 +22707,14 @@
       </p:sp>
       <p:cxnSp>
         <p:nvCxnSpPr>
-          <p:cNvPr id="38" name="Connector 37"/>
+          <p:cNvPr id="42" name="Connector 41"/>
           <p:cNvCxnSpPr/>
           <p:nvPr/>
         </p:nvCxnSpPr>
         <p:spPr>
           <a:xfrm>
-            <a:off x="9893808" y="2743200"/>
-            <a:ext cx="0" cy="594360"/>
+            <a:off x="9893808" y="3566160"/>
+            <a:ext cx="0" cy="320040"/>
           </a:xfrm>
           <a:prstGeom prst="line">
             <a:avLst/>
@@ -22297,14 +22743,14 @@
       </p:cxnSp>
       <p:cxnSp>
         <p:nvCxnSpPr>
-          <p:cNvPr id="39" name="Connector 38"/>
+          <p:cNvPr id="43" name="Connector 42"/>
           <p:cNvCxnSpPr/>
           <p:nvPr/>
         </p:nvCxnSpPr>
         <p:spPr>
           <a:xfrm flipH="1">
-            <a:off x="4206240" y="4480560"/>
-            <a:ext cx="5687568" cy="320040"/>
+            <a:off x="4206240" y="4663440"/>
+            <a:ext cx="5687568" cy="137160"/>
           </a:xfrm>
           <a:prstGeom prst="line">
             <a:avLst/>
@@ -22333,7 +22779,7 @@
       </p:cxnSp>
       <p:cxnSp>
         <p:nvCxnSpPr>
-          <p:cNvPr id="40" name="Connector 39"/>
+          <p:cNvPr id="44" name="Connector 43"/>
           <p:cNvCxnSpPr/>
           <p:nvPr/>
         </p:nvCxnSpPr>
@@ -22369,7 +22815,7 @@
       </p:cxnSp>
       <p:cxnSp>
         <p:nvCxnSpPr>
-          <p:cNvPr id="41" name="Connector 40"/>
+          <p:cNvPr id="45" name="Connector 44"/>
           <p:cNvCxnSpPr/>
           <p:nvPr/>
         </p:nvCxnSpPr>
@@ -22405,7 +22851,7 @@
       </p:cxnSp>
       <p:sp>
         <p:nvSpPr>
-          <p:cNvPr id="42" name="TextBox 41"/>
+          <p:cNvPr id="46" name="TextBox 45"/>
           <p:cNvSpPr txBox="1"/>
           <p:nvPr/>
         </p:nvSpPr>
@@ -22443,7 +22889,7 @@
                 </a:solidFill>
                 <a:latin typeface="Noto Sans CJK TC"/>
               </a:rPr>
-              <a:t>部署原則：A2A Bridge 使用獨立程序與設定，不修改既有 KB Compose、port、資料庫或 Celery worker。</a:t>
+              <a:t>部署原則：KM 可隨時 submit；Agent 可 queued / reject。Bridge 與測試端皆獨立部署，不修改既有 KM 核心。</a:t>
             </a:r>
           </a:p>
         </p:txBody>
@@ -26854,8 +27300,8 @@
                 </a:solidFill>
                 <a:latin typeface="Noto Sans CJK TC"/>
               </a:rPr>
-              <a:t>送至 Anritsu
-取得 taskId</a:t>
+              <a:t>取得 context_id
+與 a2a_task_id</a:t>
             </a:r>
           </a:p>
         </p:txBody>
@@ -27696,8 +28142,8 @@
         </p:nvSpPr>
         <p:spPr>
           <a:xfrm>
-            <a:off x="987552" y="4370832"/>
-            <a:ext cx="10149840" cy="585216"/>
+            <a:off x="987552" y="4297680"/>
+            <a:ext cx="10149840" cy="713232"/>
           </a:xfrm>
           <a:prstGeom prst="rect">
             <a:avLst/>
@@ -27722,14 +28168,14 @@
               </a:spcAft>
             </a:pPr>
             <a:r>
-              <a:rPr sz="1200" b="1">
+              <a:rPr sz="1100" b="1">
                 <a:solidFill>
                   <a:srgbClr val="0B1F33"/>
                 </a:solidFill>
                 <a:latin typeface="Noto Sans CJK TC"/>
               </a:rPr>
-              <a:t>Correlation 必須保存：A2A taskId ↔ run_id ↔ KB ingest task_id ↔ file_hash。
-A2A 回應傳 metadata，不必把 Excel 二進位內容塞入 JSON-RPC。</a:t>
+              <a:t>Canonical correlation：context_id ↔ a2a_task_id ↔ run_id ↔ ingest_task_id（另存 file_hash）。
+四個欄位名稱必須固定並持久化；retry／重啟後仍可追蹤。A2A 只傳 metadata，不把 Excel 二進位塞入訊息。</a:t>
             </a:r>
           </a:p>
         </p:txBody>

</xml_diff>